<commit_message>
Updated Suppl Figure 1
</commit_message>
<xml_diff>
--- a/SupplFigure1/SupplementaryFigure1.pptx
+++ b/SupplFigure1/SupplementaryFigure1.pptx
@@ -243,7 +243,7 @@
           <a:p>
             <a:fld id="{A4BDA5CE-77F4-40B0-91A8-2181979C7B55}" type="datetimeFigureOut">
               <a:rPr lang="en-US" smtClean="0"/>
-              <a:t>03/24/25</a:t>
+              <a:t>01/04/26</a:t>
             </a:fld>
             <a:endParaRPr lang="en-US"/>
           </a:p>
@@ -413,7 +413,7 @@
           <a:p>
             <a:fld id="{A4BDA5CE-77F4-40B0-91A8-2181979C7B55}" type="datetimeFigureOut">
               <a:rPr lang="en-US" smtClean="0"/>
-              <a:t>03/24/25</a:t>
+              <a:t>01/04/26</a:t>
             </a:fld>
             <a:endParaRPr lang="en-US"/>
           </a:p>
@@ -593,7 +593,7 @@
           <a:p>
             <a:fld id="{A4BDA5CE-77F4-40B0-91A8-2181979C7B55}" type="datetimeFigureOut">
               <a:rPr lang="en-US" smtClean="0"/>
-              <a:t>03/24/25</a:t>
+              <a:t>01/04/26</a:t>
             </a:fld>
             <a:endParaRPr lang="en-US"/>
           </a:p>
@@ -763,7 +763,7 @@
           <a:p>
             <a:fld id="{A4BDA5CE-77F4-40B0-91A8-2181979C7B55}" type="datetimeFigureOut">
               <a:rPr lang="en-US" smtClean="0"/>
-              <a:t>03/24/25</a:t>
+              <a:t>01/04/26</a:t>
             </a:fld>
             <a:endParaRPr lang="en-US"/>
           </a:p>
@@ -1009,7 +1009,7 @@
           <a:p>
             <a:fld id="{A4BDA5CE-77F4-40B0-91A8-2181979C7B55}" type="datetimeFigureOut">
               <a:rPr lang="en-US" smtClean="0"/>
-              <a:t>03/24/25</a:t>
+              <a:t>01/04/26</a:t>
             </a:fld>
             <a:endParaRPr lang="en-US"/>
           </a:p>
@@ -1241,7 +1241,7 @@
           <a:p>
             <a:fld id="{A4BDA5CE-77F4-40B0-91A8-2181979C7B55}" type="datetimeFigureOut">
               <a:rPr lang="en-US" smtClean="0"/>
-              <a:t>03/24/25</a:t>
+              <a:t>01/04/26</a:t>
             </a:fld>
             <a:endParaRPr lang="en-US"/>
           </a:p>
@@ -1608,7 +1608,7 @@
           <a:p>
             <a:fld id="{A4BDA5CE-77F4-40B0-91A8-2181979C7B55}" type="datetimeFigureOut">
               <a:rPr lang="en-US" smtClean="0"/>
-              <a:t>03/24/25</a:t>
+              <a:t>01/04/26</a:t>
             </a:fld>
             <a:endParaRPr lang="en-US"/>
           </a:p>
@@ -1726,7 +1726,7 @@
           <a:p>
             <a:fld id="{A4BDA5CE-77F4-40B0-91A8-2181979C7B55}" type="datetimeFigureOut">
               <a:rPr lang="en-US" smtClean="0"/>
-              <a:t>03/24/25</a:t>
+              <a:t>01/04/26</a:t>
             </a:fld>
             <a:endParaRPr lang="en-US"/>
           </a:p>
@@ -1821,7 +1821,7 @@
           <a:p>
             <a:fld id="{A4BDA5CE-77F4-40B0-91A8-2181979C7B55}" type="datetimeFigureOut">
               <a:rPr lang="en-US" smtClean="0"/>
-              <a:t>03/24/25</a:t>
+              <a:t>01/04/26</a:t>
             </a:fld>
             <a:endParaRPr lang="en-US"/>
           </a:p>
@@ -2098,7 +2098,7 @@
           <a:p>
             <a:fld id="{A4BDA5CE-77F4-40B0-91A8-2181979C7B55}" type="datetimeFigureOut">
               <a:rPr lang="en-US" smtClean="0"/>
-              <a:t>03/24/25</a:t>
+              <a:t>01/04/26</a:t>
             </a:fld>
             <a:endParaRPr lang="en-US"/>
           </a:p>
@@ -2355,7 +2355,7 @@
           <a:p>
             <a:fld id="{A4BDA5CE-77F4-40B0-91A8-2181979C7B55}" type="datetimeFigureOut">
               <a:rPr lang="en-US" smtClean="0"/>
-              <a:t>03/24/25</a:t>
+              <a:t>01/04/26</a:t>
             </a:fld>
             <a:endParaRPr lang="en-US"/>
           </a:p>
@@ -2568,7 +2568,7 @@
           <a:p>
             <a:fld id="{A4BDA5CE-77F4-40B0-91A8-2181979C7B55}" type="datetimeFigureOut">
               <a:rPr lang="en-US" smtClean="0"/>
-              <a:t>03/24/25</a:t>
+              <a:t>01/04/26</a:t>
             </a:fld>
             <a:endParaRPr lang="en-US"/>
           </a:p>
@@ -2975,10 +2975,10 @@
       </p:grpSpPr>
       <p:pic>
         <p:nvPicPr>
-          <p:cNvPr id="58" name="Graphic 57">
+          <p:cNvPr id="71" name="Graphic 70">
             <a:extLst>
               <a:ext uri="{FF2B5EF4-FFF2-40B4-BE49-F238E27FC236}">
-                <a16:creationId xmlns:a16="http://schemas.microsoft.com/office/drawing/2014/main" id="{1F67563E-914B-8AFA-EF9C-C5235C7D729B}"/>
+                <a16:creationId xmlns:a16="http://schemas.microsoft.com/office/drawing/2014/main" id="{DEB2A15F-96B8-B5FC-F3FD-D4947173D957}"/>
               </a:ext>
             </a:extLst>
           </p:cNvPr>
@@ -3001,434 +3001,20 @@
         </p:blipFill>
         <p:spPr>
           <a:xfrm>
-            <a:off x="2076450" y="518066"/>
-            <a:ext cx="8648700" cy="4657725"/>
+            <a:off x="24660" y="12058133"/>
+            <a:ext cx="12776940" cy="8155493"/>
           </a:xfrm>
           <a:prstGeom prst="rect">
             <a:avLst/>
           </a:prstGeom>
         </p:spPr>
       </p:pic>
-      <p:cxnSp>
-        <p:nvCxnSpPr>
-          <p:cNvPr id="59" name="Straight Connector 58">
+      <p:pic>
+        <p:nvPicPr>
+          <p:cNvPr id="3" name="Graphic 2">
             <a:extLst>
               <a:ext uri="{FF2B5EF4-FFF2-40B4-BE49-F238E27FC236}">
-                <a16:creationId xmlns:a16="http://schemas.microsoft.com/office/drawing/2014/main" id="{E6070A99-A954-0F94-6D11-922841AC2728}"/>
-              </a:ext>
-            </a:extLst>
-          </p:cNvPr>
-          <p:cNvCxnSpPr>
-            <a:cxnSpLocks/>
-          </p:cNvCxnSpPr>
-          <p:nvPr/>
-        </p:nvCxnSpPr>
-        <p:spPr>
-          <a:xfrm>
-            <a:off x="4081405" y="6232389"/>
-            <a:ext cx="1894114" cy="0"/>
-          </a:xfrm>
-          <a:prstGeom prst="line">
-            <a:avLst/>
-          </a:prstGeom>
-          <a:ln w="57150"/>
-        </p:spPr>
-        <p:style>
-          <a:lnRef idx="1">
-            <a:schemeClr val="dk1"/>
-          </a:lnRef>
-          <a:fillRef idx="0">
-            <a:schemeClr val="dk1"/>
-          </a:fillRef>
-          <a:effectRef idx="0">
-            <a:schemeClr val="dk1"/>
-          </a:effectRef>
-          <a:fontRef idx="minor">
-            <a:schemeClr val="tx1"/>
-          </a:fontRef>
-        </p:style>
-      </p:cxnSp>
-      <p:sp>
-        <p:nvSpPr>
-          <p:cNvPr id="60" name="TextBox 59">
-            <a:extLst>
-              <a:ext uri="{FF2B5EF4-FFF2-40B4-BE49-F238E27FC236}">
-                <a16:creationId xmlns:a16="http://schemas.microsoft.com/office/drawing/2014/main" id="{28753C7C-EFDB-19E1-EF5B-F9C7A08FF0EB}"/>
-              </a:ext>
-            </a:extLst>
-          </p:cNvPr>
-          <p:cNvSpPr txBox="1"/>
-          <p:nvPr/>
-        </p:nvSpPr>
-        <p:spPr>
-          <a:xfrm>
-            <a:off x="3687902" y="6192333"/>
-            <a:ext cx="2681120" cy="1077218"/>
-          </a:xfrm>
-          <a:prstGeom prst="rect">
-            <a:avLst/>
-          </a:prstGeom>
-          <a:noFill/>
-        </p:spPr>
-        <p:txBody>
-          <a:bodyPr wrap="none" rtlCol="0">
-            <a:spAutoFit/>
-          </a:bodyPr>
-          <a:lstStyle/>
-          <a:p>
-            <a:pPr algn="ctr"/>
-            <a:r>
-              <a:rPr lang="en-US" sz="3200" u="sng" dirty="0">
-                <a:latin typeface="DejaVu Sans" panose="020B0603030804020204" pitchFamily="34" charset="0"/>
-                <a:ea typeface="DejaVu Sans" panose="020B0603030804020204" pitchFamily="34" charset="0"/>
-                <a:cs typeface="DejaVu Sans" panose="020B0603030804020204" pitchFamily="34" charset="0"/>
-              </a:rPr>
-              <a:t>Viral-human</a:t>
-            </a:r>
-          </a:p>
-          <a:p>
-            <a:pPr algn="ctr"/>
-            <a:r>
-              <a:rPr lang="en-US" sz="3200" u="sng" dirty="0">
-                <a:latin typeface="DejaVu Sans" panose="020B0603030804020204" pitchFamily="34" charset="0"/>
-                <a:ea typeface="DejaVu Sans" panose="020B0603030804020204" pitchFamily="34" charset="0"/>
-                <a:cs typeface="DejaVu Sans" panose="020B0603030804020204" pitchFamily="34" charset="0"/>
-              </a:rPr>
-              <a:t>interactions</a:t>
-            </a:r>
-          </a:p>
-        </p:txBody>
-      </p:sp>
-      <p:cxnSp>
-        <p:nvCxnSpPr>
-          <p:cNvPr id="61" name="Straight Connector 60">
-            <a:extLst>
-              <a:ext uri="{FF2B5EF4-FFF2-40B4-BE49-F238E27FC236}">
-                <a16:creationId xmlns:a16="http://schemas.microsoft.com/office/drawing/2014/main" id="{39305C24-3A04-7F31-36EC-72E2C7F95808}"/>
-              </a:ext>
-            </a:extLst>
-          </p:cNvPr>
-          <p:cNvCxnSpPr>
-            <a:cxnSpLocks/>
-          </p:cNvCxnSpPr>
-          <p:nvPr/>
-        </p:nvCxnSpPr>
-        <p:spPr>
-          <a:xfrm>
-            <a:off x="7021287" y="6232389"/>
-            <a:ext cx="1894114" cy="0"/>
-          </a:xfrm>
-          <a:prstGeom prst="line">
-            <a:avLst/>
-          </a:prstGeom>
-          <a:ln w="57150"/>
-        </p:spPr>
-        <p:style>
-          <a:lnRef idx="1">
-            <a:schemeClr val="dk1"/>
-          </a:lnRef>
-          <a:fillRef idx="0">
-            <a:schemeClr val="dk1"/>
-          </a:fillRef>
-          <a:effectRef idx="0">
-            <a:schemeClr val="dk1"/>
-          </a:effectRef>
-          <a:fontRef idx="minor">
-            <a:schemeClr val="tx1"/>
-          </a:fontRef>
-        </p:style>
-      </p:cxnSp>
-      <p:sp>
-        <p:nvSpPr>
-          <p:cNvPr id="62" name="TextBox 61">
-            <a:extLst>
-              <a:ext uri="{FF2B5EF4-FFF2-40B4-BE49-F238E27FC236}">
-                <a16:creationId xmlns:a16="http://schemas.microsoft.com/office/drawing/2014/main" id="{D1B684F0-AD2A-6F93-4513-258CFA9C16C0}"/>
-              </a:ext>
-            </a:extLst>
-          </p:cNvPr>
-          <p:cNvSpPr txBox="1"/>
-          <p:nvPr/>
-        </p:nvSpPr>
-        <p:spPr>
-          <a:xfrm>
-            <a:off x="6369022" y="6192333"/>
-            <a:ext cx="3469219" cy="1077218"/>
-          </a:xfrm>
-          <a:prstGeom prst="rect">
-            <a:avLst/>
-          </a:prstGeom>
-          <a:noFill/>
-        </p:spPr>
-        <p:txBody>
-          <a:bodyPr wrap="none" rtlCol="0">
-            <a:spAutoFit/>
-          </a:bodyPr>
-          <a:lstStyle/>
-          <a:p>
-            <a:pPr algn="ctr"/>
-            <a:r>
-              <a:rPr lang="en-US" sz="3200" u="sng" dirty="0">
-                <a:latin typeface="DejaVu Sans" panose="020B0603030804020204" pitchFamily="34" charset="0"/>
-                <a:ea typeface="DejaVu Sans" panose="020B0603030804020204" pitchFamily="34" charset="0"/>
-                <a:cs typeface="DejaVu Sans" panose="020B0603030804020204" pitchFamily="34" charset="0"/>
-              </a:rPr>
-              <a:t>Bacteria-human</a:t>
-            </a:r>
-          </a:p>
-          <a:p>
-            <a:pPr algn="ctr"/>
-            <a:r>
-              <a:rPr lang="en-US" sz="3200" u="sng" dirty="0">
-                <a:latin typeface="DejaVu Sans" panose="020B0603030804020204" pitchFamily="34" charset="0"/>
-                <a:ea typeface="DejaVu Sans" panose="020B0603030804020204" pitchFamily="34" charset="0"/>
-                <a:cs typeface="DejaVu Sans" panose="020B0603030804020204" pitchFamily="34" charset="0"/>
-              </a:rPr>
-              <a:t>interactions</a:t>
-            </a:r>
-          </a:p>
-        </p:txBody>
-      </p:sp>
-      <p:sp>
-        <p:nvSpPr>
-          <p:cNvPr id="63" name="TextBox 62">
-            <a:extLst>
-              <a:ext uri="{FF2B5EF4-FFF2-40B4-BE49-F238E27FC236}">
-                <a16:creationId xmlns:a16="http://schemas.microsoft.com/office/drawing/2014/main" id="{4B8BEF60-9A82-E484-295A-343FC9BEFF6E}"/>
-              </a:ext>
-            </a:extLst>
-          </p:cNvPr>
-          <p:cNvSpPr txBox="1"/>
-          <p:nvPr/>
-        </p:nvSpPr>
-        <p:spPr>
-          <a:xfrm rot="17907094">
-            <a:off x="5275127" y="4977721"/>
-            <a:ext cx="864339" cy="461665"/>
-          </a:xfrm>
-          <a:prstGeom prst="rect">
-            <a:avLst/>
-          </a:prstGeom>
-          <a:noFill/>
-        </p:spPr>
-        <p:txBody>
-          <a:bodyPr wrap="none" rtlCol="0">
-            <a:spAutoFit/>
-          </a:bodyPr>
-          <a:lstStyle/>
-          <a:p>
-            <a:r>
-              <a:rPr lang="en-US" sz="2400" dirty="0">
-                <a:latin typeface="DejaVu Sans" panose="020B0603030804020204" pitchFamily="34" charset="0"/>
-                <a:ea typeface="DejaVu Sans" panose="020B0603030804020204" pitchFamily="34" charset="0"/>
-                <a:cs typeface="DejaVu Sans" panose="020B0603030804020204" pitchFamily="34" charset="0"/>
-              </a:rPr>
-              <a:t>Joint</a:t>
-            </a:r>
-          </a:p>
-        </p:txBody>
-      </p:sp>
-      <p:sp>
-        <p:nvSpPr>
-          <p:cNvPr id="64" name="TextBox 63">
-            <a:extLst>
-              <a:ext uri="{FF2B5EF4-FFF2-40B4-BE49-F238E27FC236}">
-                <a16:creationId xmlns:a16="http://schemas.microsoft.com/office/drawing/2014/main" id="{46C8CBDE-450F-86E7-4273-786F90C171CF}"/>
-              </a:ext>
-            </a:extLst>
-          </p:cNvPr>
-          <p:cNvSpPr txBox="1"/>
-          <p:nvPr/>
-        </p:nvSpPr>
-        <p:spPr>
-          <a:xfrm rot="17907094">
-            <a:off x="4470564" y="5017748"/>
-            <a:ext cx="955390" cy="461665"/>
-          </a:xfrm>
-          <a:prstGeom prst="rect">
-            <a:avLst/>
-          </a:prstGeom>
-          <a:noFill/>
-        </p:spPr>
-        <p:txBody>
-          <a:bodyPr wrap="none" rtlCol="0">
-            <a:spAutoFit/>
-          </a:bodyPr>
-          <a:lstStyle/>
-          <a:p>
-            <a:r>
-              <a:rPr lang="en-US" sz="2400" dirty="0">
-                <a:latin typeface="DejaVu Sans" panose="020B0603030804020204" pitchFamily="34" charset="0"/>
-                <a:ea typeface="DejaVu Sans" panose="020B0603030804020204" pitchFamily="34" charset="0"/>
-                <a:cs typeface="DejaVu Sans" panose="020B0603030804020204" pitchFamily="34" charset="0"/>
-              </a:rPr>
-              <a:t>Virus</a:t>
-            </a:r>
-          </a:p>
-        </p:txBody>
-      </p:sp>
-      <p:sp>
-        <p:nvSpPr>
-          <p:cNvPr id="65" name="TextBox 64">
-            <a:extLst>
-              <a:ext uri="{FF2B5EF4-FFF2-40B4-BE49-F238E27FC236}">
-                <a16:creationId xmlns:a16="http://schemas.microsoft.com/office/drawing/2014/main" id="{417BEBEF-835B-4319-9455-5BA6E76CD9BE}"/>
-              </a:ext>
-            </a:extLst>
-          </p:cNvPr>
-          <p:cNvSpPr txBox="1"/>
-          <p:nvPr/>
-        </p:nvSpPr>
-        <p:spPr>
-          <a:xfrm rot="17907094">
-            <a:off x="3600150" y="5127602"/>
-            <a:ext cx="1295547" cy="461665"/>
-          </a:xfrm>
-          <a:prstGeom prst="rect">
-            <a:avLst/>
-          </a:prstGeom>
-          <a:noFill/>
-        </p:spPr>
-        <p:txBody>
-          <a:bodyPr wrap="none" rtlCol="0">
-            <a:spAutoFit/>
-          </a:bodyPr>
-          <a:lstStyle/>
-          <a:p>
-            <a:r>
-              <a:rPr lang="en-US" sz="2400" dirty="0">
-                <a:latin typeface="DejaVu Sans" panose="020B0603030804020204" pitchFamily="34" charset="0"/>
-                <a:ea typeface="DejaVu Sans" panose="020B0603030804020204" pitchFamily="34" charset="0"/>
-                <a:cs typeface="DejaVu Sans" panose="020B0603030804020204" pitchFamily="34" charset="0"/>
-              </a:rPr>
-              <a:t>Human</a:t>
-            </a:r>
-          </a:p>
-        </p:txBody>
-      </p:sp>
-      <p:sp>
-        <p:nvSpPr>
-          <p:cNvPr id="66" name="TextBox 65">
-            <a:extLst>
-              <a:ext uri="{FF2B5EF4-FFF2-40B4-BE49-F238E27FC236}">
-                <a16:creationId xmlns:a16="http://schemas.microsoft.com/office/drawing/2014/main" id="{9C10DF5F-C5B5-558E-FE84-2496F2A99B49}"/>
-              </a:ext>
-            </a:extLst>
-          </p:cNvPr>
-          <p:cNvSpPr txBox="1"/>
-          <p:nvPr/>
-        </p:nvSpPr>
-        <p:spPr>
-          <a:xfrm rot="17907094">
-            <a:off x="8080308" y="4977721"/>
-            <a:ext cx="864339" cy="461665"/>
-          </a:xfrm>
-          <a:prstGeom prst="rect">
-            <a:avLst/>
-          </a:prstGeom>
-          <a:noFill/>
-        </p:spPr>
-        <p:txBody>
-          <a:bodyPr wrap="none" rtlCol="0">
-            <a:spAutoFit/>
-          </a:bodyPr>
-          <a:lstStyle/>
-          <a:p>
-            <a:r>
-              <a:rPr lang="en-US" sz="2400" dirty="0">
-                <a:latin typeface="DejaVu Sans" panose="020B0603030804020204" pitchFamily="34" charset="0"/>
-                <a:ea typeface="DejaVu Sans" panose="020B0603030804020204" pitchFamily="34" charset="0"/>
-                <a:cs typeface="DejaVu Sans" panose="020B0603030804020204" pitchFamily="34" charset="0"/>
-              </a:rPr>
-              <a:t>Joint</a:t>
-            </a:r>
-          </a:p>
-        </p:txBody>
-      </p:sp>
-      <p:sp>
-        <p:nvSpPr>
-          <p:cNvPr id="67" name="TextBox 66">
-            <a:extLst>
-              <a:ext uri="{FF2B5EF4-FFF2-40B4-BE49-F238E27FC236}">
-                <a16:creationId xmlns:a16="http://schemas.microsoft.com/office/drawing/2014/main" id="{F2148990-2A87-DDEF-8FBE-B0FF3FC5C563}"/>
-              </a:ext>
-            </a:extLst>
-          </p:cNvPr>
-          <p:cNvSpPr txBox="1"/>
-          <p:nvPr/>
-        </p:nvSpPr>
-        <p:spPr>
-          <a:xfrm rot="17907094">
-            <a:off x="6984815" y="5187267"/>
-            <a:ext cx="1465466" cy="461665"/>
-          </a:xfrm>
-          <a:prstGeom prst="rect">
-            <a:avLst/>
-          </a:prstGeom>
-          <a:noFill/>
-        </p:spPr>
-        <p:txBody>
-          <a:bodyPr wrap="none" rtlCol="0">
-            <a:spAutoFit/>
-          </a:bodyPr>
-          <a:lstStyle/>
-          <a:p>
-            <a:r>
-              <a:rPr lang="en-US" sz="2400" dirty="0">
-                <a:latin typeface="DejaVu Sans" panose="020B0603030804020204" pitchFamily="34" charset="0"/>
-                <a:ea typeface="DejaVu Sans" panose="020B0603030804020204" pitchFamily="34" charset="0"/>
-                <a:cs typeface="DejaVu Sans" panose="020B0603030804020204" pitchFamily="34" charset="0"/>
-              </a:rPr>
-              <a:t>Bacteria</a:t>
-            </a:r>
-          </a:p>
-        </p:txBody>
-      </p:sp>
-      <p:sp>
-        <p:nvSpPr>
-          <p:cNvPr id="68" name="TextBox 67">
-            <a:extLst>
-              <a:ext uri="{FF2B5EF4-FFF2-40B4-BE49-F238E27FC236}">
-                <a16:creationId xmlns:a16="http://schemas.microsoft.com/office/drawing/2014/main" id="{C73AF95F-4C8E-9106-27A2-5D799E0156F3}"/>
-              </a:ext>
-            </a:extLst>
-          </p:cNvPr>
-          <p:cNvSpPr txBox="1"/>
-          <p:nvPr/>
-        </p:nvSpPr>
-        <p:spPr>
-          <a:xfrm rot="17907094">
-            <a:off x="6405331" y="5127602"/>
-            <a:ext cx="1295547" cy="461665"/>
-          </a:xfrm>
-          <a:prstGeom prst="rect">
-            <a:avLst/>
-          </a:prstGeom>
-          <a:noFill/>
-        </p:spPr>
-        <p:txBody>
-          <a:bodyPr wrap="none" rtlCol="0">
-            <a:spAutoFit/>
-          </a:bodyPr>
-          <a:lstStyle/>
-          <a:p>
-            <a:r>
-              <a:rPr lang="en-US" sz="2400" dirty="0">
-                <a:latin typeface="DejaVu Sans" panose="020B0603030804020204" pitchFamily="34" charset="0"/>
-                <a:ea typeface="DejaVu Sans" panose="020B0603030804020204" pitchFamily="34" charset="0"/>
-                <a:cs typeface="DejaVu Sans" panose="020B0603030804020204" pitchFamily="34" charset="0"/>
-              </a:rPr>
-              <a:t>Human</a:t>
-            </a:r>
-          </a:p>
-        </p:txBody>
-      </p:sp>
-      <p:pic>
-        <p:nvPicPr>
-          <p:cNvPr id="69" name="Graphic 68">
-            <a:extLst>
-              <a:ext uri="{FF2B5EF4-FFF2-40B4-BE49-F238E27FC236}">
-                <a16:creationId xmlns:a16="http://schemas.microsoft.com/office/drawing/2014/main" id="{7FB91569-B4DB-F3AA-C167-C47A6EF46401}"/>
+                <a16:creationId xmlns:a16="http://schemas.microsoft.com/office/drawing/2014/main" id="{3A9AC91E-EFE2-F13E-0753-278D23DFB885}"/>
               </a:ext>
             </a:extLst>
           </p:cNvPr>
@@ -3451,8 +3037,8 @@
         </p:blipFill>
         <p:spPr>
           <a:xfrm>
-            <a:off x="6907837" y="8032218"/>
-            <a:ext cx="5490990" cy="4394841"/>
+            <a:off x="118872" y="7491887"/>
+            <a:ext cx="6281928" cy="4731452"/>
           </a:xfrm>
           <a:prstGeom prst="rect">
             <a:avLst/>
@@ -3461,10 +3047,10 @@
       </p:pic>
       <p:pic>
         <p:nvPicPr>
-          <p:cNvPr id="70" name="Graphic 69">
+          <p:cNvPr id="58" name="Graphic 57">
             <a:extLst>
               <a:ext uri="{FF2B5EF4-FFF2-40B4-BE49-F238E27FC236}">
-                <a16:creationId xmlns:a16="http://schemas.microsoft.com/office/drawing/2014/main" id="{9F66BA36-F585-96DD-37B0-50170CE44891}"/>
+                <a16:creationId xmlns:a16="http://schemas.microsoft.com/office/drawing/2014/main" id="{1F67563E-914B-8AFA-EF9C-C5235C7D729B}"/>
               </a:ext>
             </a:extLst>
           </p:cNvPr>
@@ -3487,20 +3073,434 @@
         </p:blipFill>
         <p:spPr>
           <a:xfrm>
-            <a:off x="118151" y="7906927"/>
-            <a:ext cx="6282649" cy="4855707"/>
+            <a:off x="2076450" y="518066"/>
+            <a:ext cx="8648700" cy="4657725"/>
           </a:xfrm>
           <a:prstGeom prst="rect">
             <a:avLst/>
           </a:prstGeom>
         </p:spPr>
       </p:pic>
+      <p:cxnSp>
+        <p:nvCxnSpPr>
+          <p:cNvPr id="59" name="Straight Connector 58">
+            <a:extLst>
+              <a:ext uri="{FF2B5EF4-FFF2-40B4-BE49-F238E27FC236}">
+                <a16:creationId xmlns:a16="http://schemas.microsoft.com/office/drawing/2014/main" id="{E6070A99-A954-0F94-6D11-922841AC2728}"/>
+              </a:ext>
+            </a:extLst>
+          </p:cNvPr>
+          <p:cNvCxnSpPr>
+            <a:cxnSpLocks/>
+          </p:cNvCxnSpPr>
+          <p:nvPr/>
+        </p:nvCxnSpPr>
+        <p:spPr>
+          <a:xfrm>
+            <a:off x="4081405" y="6232389"/>
+            <a:ext cx="1894114" cy="0"/>
+          </a:xfrm>
+          <a:prstGeom prst="line">
+            <a:avLst/>
+          </a:prstGeom>
+          <a:ln w="57150"/>
+        </p:spPr>
+        <p:style>
+          <a:lnRef idx="1">
+            <a:schemeClr val="dk1"/>
+          </a:lnRef>
+          <a:fillRef idx="0">
+            <a:schemeClr val="dk1"/>
+          </a:fillRef>
+          <a:effectRef idx="0">
+            <a:schemeClr val="dk1"/>
+          </a:effectRef>
+          <a:fontRef idx="minor">
+            <a:schemeClr val="tx1"/>
+          </a:fontRef>
+        </p:style>
+      </p:cxnSp>
+      <p:sp>
+        <p:nvSpPr>
+          <p:cNvPr id="60" name="TextBox 59">
+            <a:extLst>
+              <a:ext uri="{FF2B5EF4-FFF2-40B4-BE49-F238E27FC236}">
+                <a16:creationId xmlns:a16="http://schemas.microsoft.com/office/drawing/2014/main" id="{28753C7C-EFDB-19E1-EF5B-F9C7A08FF0EB}"/>
+              </a:ext>
+            </a:extLst>
+          </p:cNvPr>
+          <p:cNvSpPr txBox="1"/>
+          <p:nvPr/>
+        </p:nvSpPr>
+        <p:spPr>
+          <a:xfrm>
+            <a:off x="3687902" y="6192333"/>
+            <a:ext cx="2681120" cy="1077218"/>
+          </a:xfrm>
+          <a:prstGeom prst="rect">
+            <a:avLst/>
+          </a:prstGeom>
+          <a:noFill/>
+        </p:spPr>
+        <p:txBody>
+          <a:bodyPr wrap="none" rtlCol="0">
+            <a:spAutoFit/>
+          </a:bodyPr>
+          <a:lstStyle/>
+          <a:p>
+            <a:pPr algn="ctr"/>
+            <a:r>
+              <a:rPr lang="en-US" sz="3200" u="sng" dirty="0">
+                <a:latin typeface="DejaVu Sans" panose="020B0603030804020204" pitchFamily="34" charset="0"/>
+                <a:ea typeface="DejaVu Sans" panose="020B0603030804020204" pitchFamily="34" charset="0"/>
+                <a:cs typeface="DejaVu Sans" panose="020B0603030804020204" pitchFamily="34" charset="0"/>
+              </a:rPr>
+              <a:t>Viral-human</a:t>
+            </a:r>
+          </a:p>
+          <a:p>
+            <a:pPr algn="ctr"/>
+            <a:r>
+              <a:rPr lang="en-US" sz="3200" u="sng" dirty="0">
+                <a:latin typeface="DejaVu Sans" panose="020B0603030804020204" pitchFamily="34" charset="0"/>
+                <a:ea typeface="DejaVu Sans" panose="020B0603030804020204" pitchFamily="34" charset="0"/>
+                <a:cs typeface="DejaVu Sans" panose="020B0603030804020204" pitchFamily="34" charset="0"/>
+              </a:rPr>
+              <a:t>interactions</a:t>
+            </a:r>
+          </a:p>
+        </p:txBody>
+      </p:sp>
+      <p:cxnSp>
+        <p:nvCxnSpPr>
+          <p:cNvPr id="61" name="Straight Connector 60">
+            <a:extLst>
+              <a:ext uri="{FF2B5EF4-FFF2-40B4-BE49-F238E27FC236}">
+                <a16:creationId xmlns:a16="http://schemas.microsoft.com/office/drawing/2014/main" id="{39305C24-3A04-7F31-36EC-72E2C7F95808}"/>
+              </a:ext>
+            </a:extLst>
+          </p:cNvPr>
+          <p:cNvCxnSpPr>
+            <a:cxnSpLocks/>
+          </p:cNvCxnSpPr>
+          <p:nvPr/>
+        </p:nvCxnSpPr>
+        <p:spPr>
+          <a:xfrm>
+            <a:off x="7021287" y="6232389"/>
+            <a:ext cx="1894114" cy="0"/>
+          </a:xfrm>
+          <a:prstGeom prst="line">
+            <a:avLst/>
+          </a:prstGeom>
+          <a:ln w="57150"/>
+        </p:spPr>
+        <p:style>
+          <a:lnRef idx="1">
+            <a:schemeClr val="dk1"/>
+          </a:lnRef>
+          <a:fillRef idx="0">
+            <a:schemeClr val="dk1"/>
+          </a:fillRef>
+          <a:effectRef idx="0">
+            <a:schemeClr val="dk1"/>
+          </a:effectRef>
+          <a:fontRef idx="minor">
+            <a:schemeClr val="tx1"/>
+          </a:fontRef>
+        </p:style>
+      </p:cxnSp>
+      <p:sp>
+        <p:nvSpPr>
+          <p:cNvPr id="62" name="TextBox 61">
+            <a:extLst>
+              <a:ext uri="{FF2B5EF4-FFF2-40B4-BE49-F238E27FC236}">
+                <a16:creationId xmlns:a16="http://schemas.microsoft.com/office/drawing/2014/main" id="{D1B684F0-AD2A-6F93-4513-258CFA9C16C0}"/>
+              </a:ext>
+            </a:extLst>
+          </p:cNvPr>
+          <p:cNvSpPr txBox="1"/>
+          <p:nvPr/>
+        </p:nvSpPr>
+        <p:spPr>
+          <a:xfrm>
+            <a:off x="6369022" y="6192333"/>
+            <a:ext cx="3469219" cy="1077218"/>
+          </a:xfrm>
+          <a:prstGeom prst="rect">
+            <a:avLst/>
+          </a:prstGeom>
+          <a:noFill/>
+        </p:spPr>
+        <p:txBody>
+          <a:bodyPr wrap="none" rtlCol="0">
+            <a:spAutoFit/>
+          </a:bodyPr>
+          <a:lstStyle/>
+          <a:p>
+            <a:pPr algn="ctr"/>
+            <a:r>
+              <a:rPr lang="en-US" sz="3200" u="sng" dirty="0">
+                <a:latin typeface="DejaVu Sans" panose="020B0603030804020204" pitchFamily="34" charset="0"/>
+                <a:ea typeface="DejaVu Sans" panose="020B0603030804020204" pitchFamily="34" charset="0"/>
+                <a:cs typeface="DejaVu Sans" panose="020B0603030804020204" pitchFamily="34" charset="0"/>
+              </a:rPr>
+              <a:t>Bacteria-human</a:t>
+            </a:r>
+          </a:p>
+          <a:p>
+            <a:pPr algn="ctr"/>
+            <a:r>
+              <a:rPr lang="en-US" sz="3200" u="sng" dirty="0">
+                <a:latin typeface="DejaVu Sans" panose="020B0603030804020204" pitchFamily="34" charset="0"/>
+                <a:ea typeface="DejaVu Sans" panose="020B0603030804020204" pitchFamily="34" charset="0"/>
+                <a:cs typeface="DejaVu Sans" panose="020B0603030804020204" pitchFamily="34" charset="0"/>
+              </a:rPr>
+              <a:t>interactions</a:t>
+            </a:r>
+          </a:p>
+        </p:txBody>
+      </p:sp>
+      <p:sp>
+        <p:nvSpPr>
+          <p:cNvPr id="63" name="TextBox 62">
+            <a:extLst>
+              <a:ext uri="{FF2B5EF4-FFF2-40B4-BE49-F238E27FC236}">
+                <a16:creationId xmlns:a16="http://schemas.microsoft.com/office/drawing/2014/main" id="{4B8BEF60-9A82-E484-295A-343FC9BEFF6E}"/>
+              </a:ext>
+            </a:extLst>
+          </p:cNvPr>
+          <p:cNvSpPr txBox="1"/>
+          <p:nvPr/>
+        </p:nvSpPr>
+        <p:spPr>
+          <a:xfrm rot="17907094">
+            <a:off x="5149171" y="5073974"/>
+            <a:ext cx="1135504" cy="461665"/>
+          </a:xfrm>
+          <a:prstGeom prst="rect">
+            <a:avLst/>
+          </a:prstGeom>
+          <a:noFill/>
+        </p:spPr>
+        <p:txBody>
+          <a:bodyPr wrap="none" rtlCol="0">
+            <a:spAutoFit/>
+          </a:bodyPr>
+          <a:lstStyle/>
+          <a:p>
+            <a:r>
+              <a:rPr lang="en-US" sz="2400" dirty="0">
+                <a:latin typeface="DejaVu Sans" panose="020B0603030804020204" pitchFamily="34" charset="0"/>
+                <a:ea typeface="DejaVu Sans" panose="020B0603030804020204" pitchFamily="34" charset="0"/>
+                <a:cs typeface="DejaVu Sans" panose="020B0603030804020204" pitchFamily="34" charset="0"/>
+              </a:rPr>
+              <a:t>Paired</a:t>
+            </a:r>
+          </a:p>
+        </p:txBody>
+      </p:sp>
+      <p:sp>
+        <p:nvSpPr>
+          <p:cNvPr id="64" name="TextBox 63">
+            <a:extLst>
+              <a:ext uri="{FF2B5EF4-FFF2-40B4-BE49-F238E27FC236}">
+                <a16:creationId xmlns:a16="http://schemas.microsoft.com/office/drawing/2014/main" id="{46C8CBDE-450F-86E7-4273-786F90C171CF}"/>
+              </a:ext>
+            </a:extLst>
+          </p:cNvPr>
+          <p:cNvSpPr txBox="1"/>
+          <p:nvPr/>
+        </p:nvSpPr>
+        <p:spPr>
+          <a:xfrm rot="17907094">
+            <a:off x="4470564" y="5017748"/>
+            <a:ext cx="955390" cy="461665"/>
+          </a:xfrm>
+          <a:prstGeom prst="rect">
+            <a:avLst/>
+          </a:prstGeom>
+          <a:noFill/>
+        </p:spPr>
+        <p:txBody>
+          <a:bodyPr wrap="none" rtlCol="0">
+            <a:spAutoFit/>
+          </a:bodyPr>
+          <a:lstStyle/>
+          <a:p>
+            <a:r>
+              <a:rPr lang="en-US" sz="2400" dirty="0">
+                <a:latin typeface="DejaVu Sans" panose="020B0603030804020204" pitchFamily="34" charset="0"/>
+                <a:ea typeface="DejaVu Sans" panose="020B0603030804020204" pitchFamily="34" charset="0"/>
+                <a:cs typeface="DejaVu Sans" panose="020B0603030804020204" pitchFamily="34" charset="0"/>
+              </a:rPr>
+              <a:t>Virus</a:t>
+            </a:r>
+          </a:p>
+        </p:txBody>
+      </p:sp>
+      <p:sp>
+        <p:nvSpPr>
+          <p:cNvPr id="65" name="TextBox 64">
+            <a:extLst>
+              <a:ext uri="{FF2B5EF4-FFF2-40B4-BE49-F238E27FC236}">
+                <a16:creationId xmlns:a16="http://schemas.microsoft.com/office/drawing/2014/main" id="{417BEBEF-835B-4319-9455-5BA6E76CD9BE}"/>
+              </a:ext>
+            </a:extLst>
+          </p:cNvPr>
+          <p:cNvSpPr txBox="1"/>
+          <p:nvPr/>
+        </p:nvSpPr>
+        <p:spPr>
+          <a:xfrm rot="17907094">
+            <a:off x="3600150" y="5127602"/>
+            <a:ext cx="1295547" cy="461665"/>
+          </a:xfrm>
+          <a:prstGeom prst="rect">
+            <a:avLst/>
+          </a:prstGeom>
+          <a:noFill/>
+        </p:spPr>
+        <p:txBody>
+          <a:bodyPr wrap="none" rtlCol="0">
+            <a:spAutoFit/>
+          </a:bodyPr>
+          <a:lstStyle/>
+          <a:p>
+            <a:r>
+              <a:rPr lang="en-US" sz="2400" dirty="0">
+                <a:latin typeface="DejaVu Sans" panose="020B0603030804020204" pitchFamily="34" charset="0"/>
+                <a:ea typeface="DejaVu Sans" panose="020B0603030804020204" pitchFamily="34" charset="0"/>
+                <a:cs typeface="DejaVu Sans" panose="020B0603030804020204" pitchFamily="34" charset="0"/>
+              </a:rPr>
+              <a:t>Human</a:t>
+            </a:r>
+          </a:p>
+        </p:txBody>
+      </p:sp>
+      <p:sp>
+        <p:nvSpPr>
+          <p:cNvPr id="66" name="TextBox 65">
+            <a:extLst>
+              <a:ext uri="{FF2B5EF4-FFF2-40B4-BE49-F238E27FC236}">
+                <a16:creationId xmlns:a16="http://schemas.microsoft.com/office/drawing/2014/main" id="{9C10DF5F-C5B5-558E-FE84-2496F2A99B49}"/>
+              </a:ext>
+            </a:extLst>
+          </p:cNvPr>
+          <p:cNvSpPr txBox="1"/>
+          <p:nvPr/>
+        </p:nvSpPr>
+        <p:spPr>
+          <a:xfrm rot="17907094">
+            <a:off x="7954352" y="5073974"/>
+            <a:ext cx="1135504" cy="461665"/>
+          </a:xfrm>
+          <a:prstGeom prst="rect">
+            <a:avLst/>
+          </a:prstGeom>
+          <a:noFill/>
+        </p:spPr>
+        <p:txBody>
+          <a:bodyPr wrap="none" rtlCol="0">
+            <a:spAutoFit/>
+          </a:bodyPr>
+          <a:lstStyle/>
+          <a:p>
+            <a:r>
+              <a:rPr lang="en-US" sz="2400" dirty="0">
+                <a:latin typeface="DejaVu Sans" panose="020B0603030804020204" pitchFamily="34" charset="0"/>
+                <a:ea typeface="DejaVu Sans" panose="020B0603030804020204" pitchFamily="34" charset="0"/>
+                <a:cs typeface="DejaVu Sans" panose="020B0603030804020204" pitchFamily="34" charset="0"/>
+              </a:rPr>
+              <a:t>Paired</a:t>
+            </a:r>
+          </a:p>
+        </p:txBody>
+      </p:sp>
+      <p:sp>
+        <p:nvSpPr>
+          <p:cNvPr id="67" name="TextBox 66">
+            <a:extLst>
+              <a:ext uri="{FF2B5EF4-FFF2-40B4-BE49-F238E27FC236}">
+                <a16:creationId xmlns:a16="http://schemas.microsoft.com/office/drawing/2014/main" id="{F2148990-2A87-DDEF-8FBE-B0FF3FC5C563}"/>
+              </a:ext>
+            </a:extLst>
+          </p:cNvPr>
+          <p:cNvSpPr txBox="1"/>
+          <p:nvPr/>
+        </p:nvSpPr>
+        <p:spPr>
+          <a:xfrm rot="17907094">
+            <a:off x="6984815" y="5187267"/>
+            <a:ext cx="1465466" cy="461665"/>
+          </a:xfrm>
+          <a:prstGeom prst="rect">
+            <a:avLst/>
+          </a:prstGeom>
+          <a:noFill/>
+        </p:spPr>
+        <p:txBody>
+          <a:bodyPr wrap="none" rtlCol="0">
+            <a:spAutoFit/>
+          </a:bodyPr>
+          <a:lstStyle/>
+          <a:p>
+            <a:r>
+              <a:rPr lang="en-US" sz="2400" dirty="0">
+                <a:latin typeface="DejaVu Sans" panose="020B0603030804020204" pitchFamily="34" charset="0"/>
+                <a:ea typeface="DejaVu Sans" panose="020B0603030804020204" pitchFamily="34" charset="0"/>
+                <a:cs typeface="DejaVu Sans" panose="020B0603030804020204" pitchFamily="34" charset="0"/>
+              </a:rPr>
+              <a:t>Bacteria</a:t>
+            </a:r>
+          </a:p>
+        </p:txBody>
+      </p:sp>
+      <p:sp>
+        <p:nvSpPr>
+          <p:cNvPr id="68" name="TextBox 67">
+            <a:extLst>
+              <a:ext uri="{FF2B5EF4-FFF2-40B4-BE49-F238E27FC236}">
+                <a16:creationId xmlns:a16="http://schemas.microsoft.com/office/drawing/2014/main" id="{C73AF95F-4C8E-9106-27A2-5D799E0156F3}"/>
+              </a:ext>
+            </a:extLst>
+          </p:cNvPr>
+          <p:cNvSpPr txBox="1"/>
+          <p:nvPr/>
+        </p:nvSpPr>
+        <p:spPr>
+          <a:xfrm rot="17907094">
+            <a:off x="6405331" y="5127602"/>
+            <a:ext cx="1295547" cy="461665"/>
+          </a:xfrm>
+          <a:prstGeom prst="rect">
+            <a:avLst/>
+          </a:prstGeom>
+          <a:noFill/>
+        </p:spPr>
+        <p:txBody>
+          <a:bodyPr wrap="none" rtlCol="0">
+            <a:spAutoFit/>
+          </a:bodyPr>
+          <a:lstStyle/>
+          <a:p>
+            <a:r>
+              <a:rPr lang="en-US" sz="2400" dirty="0">
+                <a:latin typeface="DejaVu Sans" panose="020B0603030804020204" pitchFamily="34" charset="0"/>
+                <a:ea typeface="DejaVu Sans" panose="020B0603030804020204" pitchFamily="34" charset="0"/>
+                <a:cs typeface="DejaVu Sans" panose="020B0603030804020204" pitchFamily="34" charset="0"/>
+              </a:rPr>
+              <a:t>Human</a:t>
+            </a:r>
+          </a:p>
+        </p:txBody>
+      </p:sp>
       <p:pic>
         <p:nvPicPr>
-          <p:cNvPr id="71" name="Graphic 70">
+          <p:cNvPr id="69" name="Graphic 68">
             <a:extLst>
               <a:ext uri="{FF2B5EF4-FFF2-40B4-BE49-F238E27FC236}">
-                <a16:creationId xmlns:a16="http://schemas.microsoft.com/office/drawing/2014/main" id="{DEB2A15F-96B8-B5FC-F3FD-D4947173D957}"/>
+                <a16:creationId xmlns:a16="http://schemas.microsoft.com/office/drawing/2014/main" id="{7FB91569-B4DB-F3AA-C167-C47A6EF46401}"/>
               </a:ext>
             </a:extLst>
           </p:cNvPr>
@@ -3523,8 +3523,8 @@
         </p:blipFill>
         <p:spPr>
           <a:xfrm>
-            <a:off x="24660" y="13014094"/>
-            <a:ext cx="12776940" cy="8155493"/>
+            <a:off x="6907837" y="7491887"/>
+            <a:ext cx="5490990" cy="4394841"/>
           </a:xfrm>
           <a:prstGeom prst="rect">
             <a:avLst/>
@@ -3650,7 +3650,7 @@
         </p:nvSpPr>
         <p:spPr>
           <a:xfrm>
-            <a:off x="55095" y="12690928"/>
+            <a:off x="55095" y="11693403"/>
             <a:ext cx="511679" cy="646331"/>
           </a:xfrm>
           <a:prstGeom prst="rect">

</xml_diff>